<commit_message>
team: add Malhar as Member 5 (QA and verification); QA section in README; rebuild slides
README team table and slides team table list Malhar with the contribution text 'Assigned role; the QA tasks below were completed by Parrv.'; 'name to be added' removed from README, slide text and speaker notes. README gains a QA and verification section marked in progress. Report author block untouched.

Co-Authored-By: Claude Sonnet 5.5 <noreply@anthropic.com>
</commit_message>
<xml_diff>
--- a/tox21-phase1/slides/tox21_phase1.pptx
+++ b/tox21-phase1/slides/tox21_phase1.pptx
@@ -514,7 +514,7 @@
           <a:lstStyle/>
           <a:p>
             <a:r>
-              <a:t>Opening. We predict the outcome of 12 Tox21 toxicity assays from a molecule's structure. Phase 1 is the classical machine learning baseline and the evaluation machinery; the graph neural network is Phase 2. Team: Raghav (data, splits, Logistic Regression), Ranajeet (features, Random Forest), Parrv (repository, evaluation harness, XGBoost, tuning and final test), Abhijeet (report and analysis); the fifth member's name is still to be added in the README. Source: README team table.</a:t>
+              <a:t>Opening. We predict the outcome of 12 Tox21 toxicity assays from a molecule's structure. Phase 1 is the classical machine learning baseline and the evaluation machinery; the graph neural network is Phase 2. Team: Raghav (data, splits, Logistic Regression), Ranajeet (features, Random Forest), Parrv (repository, evaluation harness, XGBoost, tuning and final test), Abhijeet (report and analysis); Malhar is Member 5 (QA and verification); the role is assigned and the QA tasks were completed by Parrv. Source: README team table.</a:t>
             </a:r>
           </a:p>
         </p:txBody>
@@ -794,7 +794,7 @@
           <a:lstStyle/>
           <a:p>
             <a:r>
-              <a:t>Roles follow the Phase 1 team handbook and the README. Raghav: data cleaning, deduplication, EDA, splits, Logistic Regression. Ranajeet: Morgan fingerprints, RDKit descriptors, leak-free preprocessing, Random Forest. Parrv: repository structure and contract, evaluation harness, XGBoost, tuning and final-test scripts, reproducibility. Abhijeet: literature review, theory, results analysis, Tanimoto study, report. The fifth member's name is still to be added in the README. Phase 2: a graph neural network trained on the same splits and protocol, compared against these baselines. Reproducibility: make final-test regenerates results_test.csv; we reproduced all 432 rows to 1e-9.</a:t>
+              <a:t>Roles follow the Phase 1 team handbook and the README. Raghav: data cleaning, deduplication, EDA, splits, Logistic Regression. Ranajeet: Morgan fingerprints, RDKit descriptors, leak-free preprocessing, Random Forest. Parrv: repository structure and contract, evaluation harness, XGBoost, tuning and final-test scripts, reproducibility. Abhijeet: literature review, theory, results analysis, Tanimoto study, report. Malhar is Member 5 (QA and verification). The role is assigned; the QA tasks listed in the README are in progress, and those completed so far were done by Parrv. Phase 2: a graph neural network trained on the same splits and protocol, compared against these baselines. Reproducibility: make final-test regenerates results_test.csv; we reproduced all 432 rows to 1e-9.</a:t>
             </a:r>
           </a:p>
         </p:txBody>
@@ -4516,7 +4516,7 @@
                 </a:solidFill>
                 <a:latin typeface="Calibri"/>
               </a:rPr>
-              <a:t>Raghav  |  Ranajeet  |  Parrv  |  Abhijeet  |  fifth member (name to be added)</a:t>
+              <a:t>Raghav  |  Ranajeet  |  Parrv  |  Abhijeet  |  Malhar</a:t>
             </a:r>
           </a:p>
         </p:txBody>
@@ -8030,7 +8030,7 @@
                           </a:solidFill>
                           <a:latin typeface="Calibri"/>
                         </a:rPr>
-                        <a:t>Fifth member</a:t>
+                        <a:t>Malhar (Member 5, QA and verification)</a:t>
                       </a:r>
                     </a:p>
                   </a:txBody>
@@ -8053,7 +8053,7 @@
                           </a:solidFill>
                           <a:latin typeface="Calibri"/>
                         </a:rPr>
-                        <a:t>Slides, README polish, tests, viva preparation (name to be added)</a:t>
+                        <a:t>Assigned role; the QA tasks below were completed by Parrv.</a:t>
                       </a:r>
                     </a:p>
                   </a:txBody>
@@ -8089,6 +8089,22 @@
             <a:spAutoFit/>
           </a:bodyPr>
           <a:lstStyle/>
+          <a:p>
+            <a:pPr algn="l">
+              <a:spcAft>
+                <a:spcPts val="800"/>
+              </a:spcAft>
+            </a:pPr>
+            <a:r>
+              <a:rPr sz="1800" b="0">
+                <a:solidFill>
+                  <a:srgbClr val="142B4D"/>
+                </a:solidFill>
+                <a:latin typeface="Calibri"/>
+              </a:rPr>
+              <a:t>•  QA and verification (Member 5 role): in progress</a:t>
+            </a:r>
+          </a:p>
           <a:p>
             <a:pPr algn="l">
               <a:spcAft>

</xml_diff>

<commit_message>
Polish Member 5 README and presentation
</commit_message>
<xml_diff>
--- a/tox21-phase1/slides/tox21_phase1.pptx
+++ b/tox21-phase1/slides/tox21_phase1.pptx
@@ -794,7 +794,7 @@
           <a:lstStyle/>
           <a:p>
             <a:r>
-              <a:t>Roles follow the Phase 1 team handbook and the README. Raghav: data cleaning, deduplication, EDA, splits, Logistic Regression. Ranajeet: Morgan fingerprints, RDKit descriptors, leak-free preprocessing, Random Forest. Parrv: repository structure and contract, evaluation harness, XGBoost, tuning and final-test scripts, reproducibility. Abhijeet: literature review, theory, results analysis, Tanimoto study, report. Malhar is Member 5 (QA and verification). The role is assigned; the QA tasks listed in the README are in progress, and those completed so far were done by Parrv. Phase 2: a graph neural network trained on the same splits and protocol, compared against these baselines. Reproducibility: make final-test regenerates results_test.csv; we reproduced all 432 rows to 1e-9.</a:t>
+              <a:t>Roles follow the Phase 1 team handbook and the README. Raghav: data cleaning, deduplication, EDA, splits, Logistic Regression. Ranajeet: Morgan fingerprints, RDKit descriptors, leak-free preprocessing, Random Forest. Parrv: repository structure and contract, evaluation harness, XGBoost, tuning and final-test scripts, reproducibility. Abhijeet: literature review, theory, results analysis, Tanimoto study, report. Malhar is Member 5. The team presentation lists README and slide polish, tests, and viva preparation; the README describes the role as QA and verification. The committed QA report says the 200-molecule smoke test and final-result reproduction were completed by Parrv, while the viva drill remains unrun. Known QA item: 01_eda.ipynb fails as committed because it expects a Google Colab path; the report proposes a portable-path fix. Phase 2 is a graph neural network evaluated on the same splits and protocol. Reproducibility: the QA report records that make final-test reproduced all 432 result rows to 1e-9.</a:t>
             </a:r>
           </a:p>
         </p:txBody>
@@ -4405,7 +4405,50 @@
       </p:sp>
       <p:sp>
         <p:nvSpPr>
-          <p:cNvPr id="3" name="TextBox 2"/>
+          <p:cNvPr id="3" name="Rectangle 2"/>
+          <p:cNvSpPr/>
+          <p:nvPr/>
+        </p:nvSpPr>
+        <p:spPr>
+          <a:xfrm>
+            <a:off x="566928" y="1755648"/>
+            <a:ext cx="73152" cy="3566160"/>
+          </a:xfrm>
+          <a:prstGeom prst="rect">
+            <a:avLst/>
+          </a:prstGeom>
+          <a:solidFill>
+            <a:srgbClr val="1B7F8C"/>
+          </a:solidFill>
+          <a:ln>
+            <a:noFill/>
+          </a:ln>
+        </p:spPr>
+        <p:style>
+          <a:lnRef idx="1">
+            <a:schemeClr val="accent1"/>
+          </a:lnRef>
+          <a:fillRef idx="3">
+            <a:schemeClr val="accent1"/>
+          </a:fillRef>
+          <a:effectRef idx="2">
+            <a:schemeClr val="accent1"/>
+          </a:effectRef>
+          <a:fontRef idx="minor">
+            <a:schemeClr val="lt1"/>
+          </a:fontRef>
+        </p:style>
+        <p:txBody>
+          <a:bodyPr rtlCol="0" anchor="ctr"/>
+          <a:lstStyle/>
+          <a:p>
+            <a:pPr algn="ctr"/>
+          </a:p>
+        </p:txBody>
+      </p:sp>
+      <p:sp>
+        <p:nvSpPr>
+          <p:cNvPr id="4" name="TextBox 3"/>
           <p:cNvSpPr txBox="1"/>
           <p:nvPr/>
         </p:nvSpPr>
@@ -4444,7 +4487,7 @@
       </p:sp>
       <p:sp>
         <p:nvSpPr>
-          <p:cNvPr id="4" name="TextBox 3"/>
+          <p:cNvPr id="5" name="TextBox 4"/>
           <p:cNvSpPr txBox="1"/>
           <p:nvPr/>
         </p:nvSpPr>
@@ -4484,14 +4527,14 @@
       </p:sp>
       <p:sp>
         <p:nvSpPr>
-          <p:cNvPr id="5" name="TextBox 4"/>
+          <p:cNvPr id="6" name="TextBox 5"/>
           <p:cNvSpPr txBox="1"/>
           <p:nvPr/>
         </p:nvSpPr>
         <p:spPr>
           <a:xfrm>
-            <a:off x="822960" y="5120640"/>
-            <a:ext cx="10515600" cy="822960"/>
+            <a:off x="822960" y="4709160"/>
+            <a:ext cx="10515600" cy="411480"/>
           </a:xfrm>
           <a:prstGeom prst="rect">
             <a:avLst/>
@@ -4510,9 +4553,48 @@
               </a:spcAft>
             </a:pPr>
             <a:r>
-              <a:rPr sz="1800" b="0">
+              <a:rPr sz="1700" b="1">
                 <a:solidFill>
                   <a:srgbClr val="FFFFFF"/>
+                </a:solidFill>
+                <a:latin typeface="Calibri"/>
+              </a:rPr>
+              <a:t>7,709 molecules     •     12 assay endpoints     •     3 model families</a:t>
+            </a:r>
+          </a:p>
+        </p:txBody>
+      </p:sp>
+      <p:sp>
+        <p:nvSpPr>
+          <p:cNvPr id="7" name="TextBox 6"/>
+          <p:cNvSpPr txBox="1"/>
+          <p:nvPr/>
+        </p:nvSpPr>
+        <p:spPr>
+          <a:xfrm>
+            <a:off x="822960" y="5440680"/>
+            <a:ext cx="10515600" cy="457200"/>
+          </a:xfrm>
+          <a:prstGeom prst="rect">
+            <a:avLst/>
+          </a:prstGeom>
+          <a:noFill/>
+        </p:spPr>
+        <p:txBody>
+          <a:bodyPr wrap="square" anchor="t" lIns="45720" rIns="45720">
+            <a:spAutoFit/>
+          </a:bodyPr>
+          <a:lstStyle/>
+          <a:p>
+            <a:pPr algn="l">
+              <a:spcAft>
+                <a:spcPts val="800"/>
+              </a:spcAft>
+            </a:pPr>
+            <a:r>
+              <a:rPr sz="1600" b="0">
+                <a:solidFill>
+                  <a:srgbClr val="BFE3E8"/>
                 </a:solidFill>
                 <a:latin typeface="Calibri"/>
               </a:rPr>
@@ -7628,7 +7710,7 @@
                 </a:solidFill>
                 <a:latin typeface="Calibri"/>
               </a:rPr>
-              <a:t>Team contributions and Phase 2</a:t>
+              <a:t>Team contributions, QA and next steps</a:t>
             </a:r>
           </a:p>
         </p:txBody>
@@ -8030,7 +8112,7 @@
                           </a:solidFill>
                           <a:latin typeface="Calibri"/>
                         </a:rPr>
-                        <a:t>Malhar (Member 5, QA and verification)</a:t>
+                        <a:t>Malhar (Member 5)</a:t>
                       </a:r>
                     </a:p>
                   </a:txBody>
@@ -8053,7 +8135,7 @@
                           </a:solidFill>
                           <a:latin typeface="Calibri"/>
                         </a:rPr>
-                        <a:t>Assigned role; the QA tasks below were completed by Parrv.</a:t>
+                        <a:t>README and slide polish, tests, QA communication, viva preparation</a:t>
                       </a:r>
                     </a:p>
                   </a:txBody>
@@ -8070,71 +8152,192 @@
       </p:graphicFrame>
       <p:sp>
         <p:nvSpPr>
-          <p:cNvPr id="7" name="TextBox 6"/>
-          <p:cNvSpPr txBox="1"/>
+          <p:cNvPr id="7" name="Rounded Rectangle 6"/>
+          <p:cNvSpPr/>
           <p:nvPr/>
         </p:nvSpPr>
         <p:spPr>
           <a:xfrm>
             <a:off x="548640" y="4663440"/>
-            <a:ext cx="11064240" cy="1645920"/>
+            <a:ext cx="3520440" cy="1325880"/>
           </a:xfrm>
-          <a:prstGeom prst="rect">
+          <a:prstGeom prst="roundRect">
             <a:avLst/>
           </a:prstGeom>
-          <a:noFill/>
+          <a:solidFill>
+            <a:srgbClr val="1B7F8C"/>
+          </a:solidFill>
+          <a:ln>
+            <a:noFill/>
+          </a:ln>
         </p:spPr>
-        <p:txBody>
-          <a:bodyPr wrap="square" anchor="t" lIns="45720" rIns="45720">
-            <a:spAutoFit/>
-          </a:bodyPr>
+        <p:style>
+          <a:lnRef idx="1">
+            <a:schemeClr val="accent1"/>
+          </a:lnRef>
+          <a:fillRef idx="3">
+            <a:schemeClr val="accent1"/>
+          </a:fillRef>
+          <a:effectRef idx="2">
+            <a:schemeClr val="accent1"/>
+          </a:effectRef>
+          <a:fontRef idx="minor">
+            <a:schemeClr val="lt1"/>
+          </a:fontRef>
+        </p:style>
+        <p:txBody>
+          <a:bodyPr rtlCol="0" anchor="ctr" wrap="square" lIns="73152" rIns="73152"/>
           <a:lstStyle/>
           <a:p>
-            <a:pPr algn="l">
-              <a:spcAft>
-                <a:spcPts val="800"/>
-              </a:spcAft>
-            </a:pPr>
-            <a:r>
-              <a:rPr sz="1800" b="0">
+            <a:pPr algn="ctr"/>
+            <a:r>
+              <a:rPr sz="1500" b="1">
                 <a:solidFill>
-                  <a:srgbClr val="142B4D"/>
+                  <a:srgbClr val="FFFFFF"/>
                 </a:solidFill>
                 <a:latin typeface="Calibri"/>
               </a:rPr>
-              <a:t>•  QA and verification (Member 5 role): in progress</a:t>
-            </a:r>
-          </a:p>
-          <a:p>
-            <a:pPr algn="l">
-              <a:spcAft>
-                <a:spcPts val="800"/>
-              </a:spcAft>
-            </a:pPr>
-            <a:r>
-              <a:rPr sz="1800" b="0">
+              <a:t>QA RECORD</a:t>
+            </a:r>
+          </a:p>
+          <a:p>
+            <a:pPr algn="ctr"/>
+            <a:r>
+              <a:rPr sz="1200" b="0">
                 <a:solidFill>
-                  <a:srgbClr val="142B4D"/>
+                  <a:srgbClr val="FFFFFF"/>
                 </a:solidFill>
                 <a:latin typeface="Calibri"/>
               </a:rPr>
-              <a:t>•  Phase 2: a graph neural network on the same splits and protocol, compared with these baselines</a:t>
-            </a:r>
-          </a:p>
-          <a:p>
-            <a:pPr algn="l">
-              <a:spcAft>
-                <a:spcPts val="800"/>
-              </a:spcAft>
-            </a:pPr>
-            <a:r>
-              <a:rPr sz="1800" b="0">
+              <a:t>Smoke test and 432-row reproduction documented by Parrv</a:t>
+            </a:r>
+          </a:p>
+        </p:txBody>
+      </p:sp>
+      <p:sp>
+        <p:nvSpPr>
+          <p:cNvPr id="8" name="Rounded Rectangle 7"/>
+          <p:cNvSpPr/>
+          <p:nvPr/>
+        </p:nvSpPr>
+        <p:spPr>
+          <a:xfrm>
+            <a:off x="4343400" y="4663440"/>
+            <a:ext cx="3520440" cy="1325880"/>
+          </a:xfrm>
+          <a:prstGeom prst="roundRect">
+            <a:avLst/>
+          </a:prstGeom>
+          <a:solidFill>
+            <a:srgbClr val="142B4D"/>
+          </a:solidFill>
+          <a:ln>
+            <a:noFill/>
+          </a:ln>
+        </p:spPr>
+        <p:style>
+          <a:lnRef idx="1">
+            <a:schemeClr val="accent1"/>
+          </a:lnRef>
+          <a:fillRef idx="3">
+            <a:schemeClr val="accent1"/>
+          </a:fillRef>
+          <a:effectRef idx="2">
+            <a:schemeClr val="accent1"/>
+          </a:effectRef>
+          <a:fontRef idx="minor">
+            <a:schemeClr val="lt1"/>
+          </a:fontRef>
+        </p:style>
+        <p:txBody>
+          <a:bodyPr rtlCol="0" anchor="ctr" wrap="square" lIns="73152" rIns="73152"/>
+          <a:lstStyle/>
+          <a:p>
+            <a:pPr algn="ctr"/>
+            <a:r>
+              <a:rPr sz="1500" b="1">
                 <a:solidFill>
-                  <a:srgbClr val="142B4D"/>
+                  <a:srgbClr val="FFFFFF"/>
                 </a:solidFill>
                 <a:latin typeface="Calibri"/>
               </a:rPr>
-              <a:t>•  Reproducible: make final-test regenerates results_test.csv (432 rows; matched the committed file to 1e-9)</a:t>
+              <a:t>MEMBER 5 FOCUS</a:t>
+            </a:r>
+          </a:p>
+          <a:p>
+            <a:pPr algn="ctr"/>
+            <a:r>
+              <a:rPr sz="1200" b="0">
+                <a:solidFill>
+                  <a:srgbClr val="FFFFFF"/>
+                </a:solidFill>
+                <a:latin typeface="Calibri"/>
+              </a:rPr>
+              <a:t>README and slides, verification notes, viva preparation</a:t>
+            </a:r>
+          </a:p>
+        </p:txBody>
+      </p:sp>
+      <p:sp>
+        <p:nvSpPr>
+          <p:cNvPr id="9" name="Rounded Rectangle 8"/>
+          <p:cNvSpPr/>
+          <p:nvPr/>
+        </p:nvSpPr>
+        <p:spPr>
+          <a:xfrm>
+            <a:off x="8138160" y="4663440"/>
+            <a:ext cx="3520440" cy="1325880"/>
+          </a:xfrm>
+          <a:prstGeom prst="roundRect">
+            <a:avLst/>
+          </a:prstGeom>
+          <a:solidFill>
+            <a:srgbClr val="B23A3A"/>
+          </a:solidFill>
+          <a:ln>
+            <a:noFill/>
+          </a:ln>
+        </p:spPr>
+        <p:style>
+          <a:lnRef idx="1">
+            <a:schemeClr val="accent1"/>
+          </a:lnRef>
+          <a:fillRef idx="3">
+            <a:schemeClr val="accent1"/>
+          </a:fillRef>
+          <a:effectRef idx="2">
+            <a:schemeClr val="accent1"/>
+          </a:effectRef>
+          <a:fontRef idx="minor">
+            <a:schemeClr val="lt1"/>
+          </a:fontRef>
+        </p:style>
+        <p:txBody>
+          <a:bodyPr rtlCol="0" anchor="ctr" wrap="square" lIns="73152" rIns="73152"/>
+          <a:lstStyle/>
+          <a:p>
+            <a:pPr algn="ctr"/>
+            <a:r>
+              <a:rPr sz="1500" b="1">
+                <a:solidFill>
+                  <a:srgbClr val="FFFFFF"/>
+                </a:solidFill>
+                <a:latin typeface="Calibri"/>
+              </a:rPr>
+              <a:t>OPEN ITEMS</a:t>
+            </a:r>
+          </a:p>
+          <a:p>
+            <a:pPr algn="ctr"/>
+            <a:r>
+              <a:rPr sz="1200" b="0">
+                <a:solidFill>
+                  <a:srgbClr val="FFFFFF"/>
+                </a:solidFill>
+                <a:latin typeface="Calibri"/>
+              </a:rPr>
+              <a:t>Viva drill pending; 01_eda notebook uses a Colab path</a:t>
             </a:r>
           </a:p>
         </p:txBody>

</xml_diff>

<commit_message>
Remove QA completion attribution
</commit_message>
<xml_diff>
--- a/tox21-phase1/slides/tox21_phase1.pptx
+++ b/tox21-phase1/slides/tox21_phase1.pptx
@@ -514,7 +514,7 @@
           <a:lstStyle/>
           <a:p>
             <a:r>
-              <a:t>Opening. We predict the outcome of 12 Tox21 toxicity assays from a molecule's structure. Phase 1 is the classical machine learning baseline and the evaluation machinery; the graph neural network is Phase 2. Team: Raghav (data, splits, Logistic Regression), Ranajeet (features, Random Forest), Parrv (repository, evaluation harness, XGBoost, tuning and final test), Abhijeet (report and analysis); Malhar is Member 5 (QA and verification); the role is assigned and the QA tasks were completed by Parrv. Source: README team table.</a:t>
+              <a:t>Opening. We predict the outcome of 12 Tox21 toxicity assays from a molecule's structure. Phase 1 is the classical machine learning baseline and the evaluation machinery; the graph neural network is Phase 2. Team: Raghav (data, splits, Logistic Regression), Ranajeet (features, Random Forest), Parrv (repository, evaluation harness, XGBoost, tuning and final test), Abhijeet (report and analysis); Malhar is Member 5 (QA and verification); the QA report documents the verification results. Source: README team table.</a:t>
             </a:r>
           </a:p>
         </p:txBody>
@@ -794,7 +794,7 @@
           <a:lstStyle/>
           <a:p>
             <a:r>
-              <a:t>Roles follow the Phase 1 team handbook and the README. Raghav: data cleaning, deduplication, EDA, splits, Logistic Regression. Ranajeet: Morgan fingerprints, RDKit descriptors, leak-free preprocessing, Random Forest. Parrv: repository structure and contract, evaluation harness, XGBoost, tuning and final-test scripts, reproducibility. Abhijeet: literature review, theory, results analysis, Tanimoto study, report. Malhar is Member 5. The team presentation lists README and slide polish, tests, and viva preparation; the README describes the role as QA and verification. The committed QA report says the 200-molecule smoke test and final-result reproduction were completed by Parrv, while the viva drill remains unrun. Known QA item: 01_eda.ipynb fails as committed because it expects a Google Colab path; the report proposes a portable-path fix. Phase 2 is a graph neural network evaluated on the same splits and protocol. Reproducibility: the QA report records that make final-test reproduced all 432 result rows to 1e-9.</a:t>
+              <a:t>Roles follow the Phase 1 team handbook and the README. Raghav: data cleaning, deduplication, EDA, splits, Logistic Regression. Ranajeet: Morgan fingerprints, RDKit descriptors, leak-free preprocessing, Random Forest. Parrv: repository structure and contract, evaluation harness, XGBoost, tuning and final-test scripts, reproducibility. Abhijeet: literature review, theory, results analysis, Tanimoto study, report. Malhar is Member 5. The team presentation lists README and slide polish, tests, and viva preparation; the README describes the role as QA and verification. The committed QA report documents the 200-molecule smoke test and final-result reproduction, while the viva drill remains unrun. Known QA item: 01_eda.ipynb fails as committed because it expects a Google Colab path; the report proposes a portable-path fix. Phase 2 is a graph neural network evaluated on the same splits and protocol. Reproducibility: the QA report records that make final-test reproduced all 432 result rows to 1e-9.</a:t>
             </a:r>
           </a:p>
         </p:txBody>
@@ -8209,7 +8209,7 @@
                 </a:solidFill>
                 <a:latin typeface="Arial"/>
               </a:rPr>
-              <a:t>Smoke test and 432-row reproduction documented by Parrv</a:t>
+              <a:t>Smoke test and 432-row reproduction documented in the QA report</a:t>
             </a:r>
           </a:p>
         </p:txBody>

</xml_diff>